<commit_message>
feat: Update program flow with Keynotes Ms. Elduayan & Ms. Sta. Maria and synthesis session
</commit_message>
<xml_diff>
--- a/PECS_2026_Animated_Presentation.pptx
+++ b/PECS_2026_Animated_Presentation.pptx
@@ -3450,7 +3450,7 @@
             </a:r>
             <a:br/>
             <a:r>
-              <a:t>8:30 AM – 3:30 PM (7-Hour Program)</a:t>
+              <a:t>8:00 AM – 12:00 NN (Morning Plenary)</a:t>
             </a:r>
           </a:p>
         </p:txBody>
@@ -3652,7 +3652,7 @@
             </a:r>
             <a:br/>
             <a:r>
-              <a:t>BSHM, BSTM, Faculty &amp; Leaders</a:t>
+              <a:t>BSHM, BSTM, Faculty &amp; VIPs</a:t>
             </a:r>
           </a:p>
         </p:txBody>
@@ -4152,7 +4152,7 @@
               </a:defRPr>
             </a:pPr>
             <a:r>
-              <a:t>Launch targeted countdown graphics and keynote speaker spot-highlights across CHTM departmental Facebook &amp; Instagram pages starting September 7, 2026 (10 days prior).</a:t>
+              <a:t>Launch targeted countdown graphics and keynote speaker spot-highlights (Ms. Elduayan &amp; Ms. Sta. Maria) across CHTM Facebook &amp; Instagram starting Sept 7, 2026.</a:t>
             </a:r>
           </a:p>
         </p:txBody>
@@ -5506,7 +5506,7 @@
               </a:defRPr>
             </a:pPr>
             <a:r>
-              <a:t>Coordinates travel logistics, VIP holding room hospitality, honoraria distribution, and dedicated stage escorting for keynote speakers and panelists.</a:t>
+              <a:t>Coordinates travel logistics, VIP holding room hospitality, honoraria distribution, and dedicated stage escorting for keynote speakers.</a:t>
             </a:r>
           </a:p>
         </p:txBody>
@@ -7912,7 +7912,7 @@
               </a:defRPr>
             </a:pPr>
             <a:r>
-              <a:t>📬 Target Honoree:</a:t>
+              <a:t>📬 Target Honorees:</a:t>
             </a:r>
           </a:p>
           <a:p>
@@ -7928,7 +7928,7 @@
               </a:defRPr>
             </a:pPr>
             <a:r>
-              <a:t>[Speaker's Name / Title], [Organization Name]</a:t>
+              <a:t>Ms. Maria Luisa A. Elduayan &amp; Felice Prudente Sta. Maria</a:t>
             </a:r>
           </a:p>
           <a:p>
@@ -7960,7 +7960,7 @@
               </a:defRPr>
             </a:pPr>
             <a:r>
-              <a:t>45-Minute Plenary Presentation + 15-Minute Open Floor Q&amp;A</a:t>
+              <a:t>40-Minute Plenary Presentation + 25-Minute Interactive Q&amp;A</a:t>
             </a:r>
           </a:p>
           <a:p>
@@ -8158,7 +8158,7 @@
               </a:defRPr>
             </a:pPr>
             <a:r>
-              <a:t>Dear [Speaker's Name],</a:t>
+              <a:t>Dear [Speaker's Name / Esteemed Keynote Guest],</a:t>
             </a:r>
           </a:p>
           <a:p>
@@ -8195,7 +8195,7 @@
               </a:defRPr>
             </a:pPr>
             <a:r>
-              <a:t>Our conference theme, “Sustaining the Coastline: Strategies for Eco-Tourism Development and Heritage Culinary Preservation in Pangasinan,” aims to equip 500+ undergraduate delegates with actionable strategies for sustainable hospitality growth. Given your distinguished expertise, we would be honored to have you deliver a 45-minute presentation followed by a 15-minute open Q&amp;A session.</a:t>
+              <a:t>Our conference theme, “Sustaining the Coastline: Strategies for Eco-Tourism Development and Heritage Culinary Preservation in Pangasinan,” aims to equip 500+ undergraduate delegates with actionable strategies for sustainable hospitality growth. Given your distinguished expertise, we would be honored to have you deliver a 40-minute presentation followed by a 25-minute interactive Q&amp;A session.</a:t>
             </a:r>
           </a:p>
           <a:p>
@@ -8767,7 +8767,7 @@
               </a:defRPr>
             </a:pPr>
             <a:r>
-              <a:t>Thursday, September 17, 2026 (8:00 AM – 4:00 PM)</a:t>
+              <a:t>Thursday, September 17, 2026 (7:30 AM – 1:00 PM)</a:t>
             </a:r>
           </a:p>
           <a:p>
@@ -8949,7 +8949,7 @@
               </a:defRPr>
             </a:pPr>
             <a:r>
-              <a:t>The organizing committee of PECS 2026 respectfully requests class excuse for participating BSHM and BSTM student organizers and registered delegates on Thursday, September 17, 2026, from 8:00 AM to 4:00 PM.</a:t>
+              <a:t>The organizing committee of PECS 2026 respectfully requests class excuse for participating BSHM and BSTM student organizers and registered delegates on Thursday, September 17, 2026, from 7:30 AM to 1:00 PM.</a:t>
             </a:r>
           </a:p>
           <a:p>
@@ -9474,7 +9474,7 @@
               </a:defRPr>
             </a:pPr>
             <a:r>
-              <a:t>• Date &amp; Operational Time: September 17, 2026 | 7:00 AM – 5:00 PM (Including ingress, plenary sessions, and egress)</a:t>
+              <a:t>• Date &amp; Operational Time: September 17, 2026 | 7:00 AM – 1:00 PM (Including ingress, plenary sessions, and egress)</a:t>
             </a:r>
           </a:p>
           <a:p>
@@ -9739,7 +9739,7 @@
               </a:defRPr>
             </a:pPr>
             <a:r>
-              <a:t>PECS 2026 bridges academic rigor with regional hospitality excellence, providing BAM 205 students with hands-on event execution mastery.</a:t>
+              <a:t>PECS 2026 bridges academic rigor with regional hospitality excellence, empowering BAM 205 students with hands-on event execution mastery.</a:t>
             </a:r>
           </a:p>
         </p:txBody>
@@ -10030,7 +10030,7 @@
               </a:defRPr>
             </a:pPr>
             <a:r>
-              <a:t>Creates actionable partnerships between academia, local government units (LGUs), municipal tourism officers, and regional hospitality stakeholders.</a:t>
+              <a:t>Creates actionable partnerships between academia, local government units (LGUs), provincial tourism leaders, and cultural authors.</a:t>
             </a:r>
           </a:p>
         </p:txBody>
@@ -10764,7 +10764,7 @@
               </a:defRPr>
             </a:pPr>
             <a:r>
-              <a:t>🌿 Eco-Haven Focus</a:t>
+              <a:t>🌿 Coastal Eco-Tourism Frameworks</a:t>
             </a:r>
           </a:p>
           <a:p>
@@ -10780,7 +10780,7 @@
               </a:defRPr>
             </a:pPr>
             <a:r>
-              <a:t>Addressing coastal environmental preservation, carrying capacity, and eco-tourism frameworks in Lingayen Gulf and Pangasinan municipalities.</a:t>
+              <a:t>Keynote by Ms. Maria Luisa A. Elduayan on carrying capacity and shoreline sustainability in Pangasinan coastal destinations.</a:t>
             </a:r>
           </a:p>
           <a:p>
@@ -10796,7 +10796,7 @@
               </a:defRPr>
             </a:pPr>
             <a:r>
-              <a:t>🍲 Heritage Culinary Innovation</a:t>
+              <a:t>🍲 Gastronomy &amp; Culinary Heritage</a:t>
             </a:r>
           </a:p>
           <a:p>
@@ -10812,7 +10812,7 @@
               </a:defRPr>
             </a:pPr>
             <a:r>
-              <a:t>Safeguarding authentic regional gastronomic treasures (Bangus, Alaminos Longganisa, Kakanin) while integrating modern culinary and hospitality techniques.</a:t>
+              <a:t>Keynote by Felice Prudente Sta. Maria on preserving authentic flavor profiles and integrating them into modern tourism.</a:t>
             </a:r>
           </a:p>
           <a:p>
@@ -10828,7 +10828,7 @@
               </a:defRPr>
             </a:pPr>
             <a:r>
-              <a:t>🎓 Academic &amp; Industry Synergy</a:t>
+              <a:t>🎓 Interactive Synthesis &amp; Dialogue</a:t>
             </a:r>
           </a:p>
           <a:p>
@@ -10844,7 +10844,7 @@
               </a:defRPr>
             </a:pPr>
             <a:r>
-              <a:t>Bridging classroom theoretical knowledge with live industry insights, research presentations, and municipal tourism governance.</a:t>
+              <a:t>Multi-stakeholder Q&amp;A, faculty synthesis connecting food systems with eco-tourism, and student networking.</a:t>
             </a:r>
           </a:p>
         </p:txBody>
@@ -11340,7 +11340,7 @@
               </a:defRPr>
             </a:pPr>
             <a:r>
-              <a:t>01. PLENARY KEYNOTES</a:t>
+              <a:t>01. PLENARY KEYNOTE 1</a:t>
             </a:r>
           </a:p>
         </p:txBody>
@@ -11376,7 +11376,7 @@
               </a:defRPr>
             </a:pPr>
             <a:r>
-              <a:t>Expert Dialogues</a:t>
+              <a:t>Ms. Maria Luisa A. Elduayan</a:t>
             </a:r>
           </a:p>
           <a:p>
@@ -11392,7 +11392,7 @@
               </a:defRPr>
             </a:pPr>
             <a:r>
-              <a:t>Gathering municipal tourism officers, resort general managers, and local culinary historians to present frameworks on coastal carrying capacity and indigenous gastronomic preservation.</a:t>
+              <a:t>“Protecting Pangasinan’s Shorelines: Sustainable Eco-Tourism Strategies and Carrying Capacity in Coastal Destinations”</a:t>
             </a:r>
           </a:p>
         </p:txBody>
@@ -11490,7 +11490,7 @@
               </a:defRPr>
             </a:pPr>
             <a:r>
-              <a:t>02. RESEARCH COLLOQUIUM</a:t>
+              <a:t>02. PLENARY KEYNOTE 2</a:t>
             </a:r>
           </a:p>
         </p:txBody>
@@ -11526,7 +11526,7 @@
               </a:defRPr>
             </a:pPr>
             <a:r>
-              <a:t>Student Innovation</a:t>
+              <a:t>Felice Prudente Sta. Maria</a:t>
             </a:r>
           </a:p>
           <a:p>
@@ -11542,7 +11542,7 @@
               </a:defRPr>
             </a:pPr>
             <a:r>
-              <a:t>Oral presentations of 4 shortlisted student research papers addressing empirical resort models, community eco-tourism, and sustainable heritage practices.</a:t>
+              <a:t>“From Coastal Waters to Heritage Plates: Preserving Pangasinan’s Culinary Identity in Modern Gastronomy Tourism”</a:t>
             </a:r>
           </a:p>
         </p:txBody>
@@ -11640,7 +11640,7 @@
               </a:defRPr>
             </a:pPr>
             <a:r>
-              <a:t>03. MULTI-STAKEHOLDER Q&amp;A</a:t>
+              <a:t>03. SYNTHESIS &amp; DIALOGUE</a:t>
             </a:r>
           </a:p>
         </p:txBody>
@@ -11676,7 +11676,7 @@
               </a:defRPr>
             </a:pPr>
             <a:r>
-              <a:t>Open Academic Forum</a:t>
+              <a:t>CHTM Faculty &amp; Delegates</a:t>
             </a:r>
           </a:p>
           <a:p>
@@ -11692,7 +11692,7 @@
               </a:defRPr>
             </a:pPr>
             <a:r>
-              <a:t>Direct interactive floor microphone sessions bridging BSHM/BSTM students with practitioners, fostering active inquiry and policy recommendations.</a:t>
+              <a:t>Interactive floor Q&amp;A open forum, synthesis session connecting food systems, and formal recognition ceremony.</a:t>
             </a:r>
           </a:p>
         </p:txBody>
@@ -12207,19 +12207,15 @@
               </a:defRPr>
             </a:pPr>
             <a:r>
-              <a:t>• Practical industry insights beyond textbooks</a:t>
+              <a:t>• Direct learning from national &amp; regional tourism experts</a:t>
             </a:r>
             <a:br/>
             <a:r>
-              <a:t>• Peer research validation &amp; academic exchange</a:t>
+              <a:t>• Peer academic interaction &amp; Q&amp;A participation</a:t>
             </a:r>
             <a:br/>
             <a:r>
-              <a:t>• Professional networking opportunities</a:t>
-            </a:r>
-            <a:br/>
-            <a:r>
-              <a:t>• Complete conference kits (ID badge, notepad, program, bag, e-certificate)</a:t>
+              <a:t>• Complete conference kits (ID badge, notepad, program, tote bag, e-certificate)</a:t>
             </a:r>
           </a:p>
         </p:txBody>
@@ -12353,7 +12349,7 @@
               </a:defRPr>
             </a:pPr>
             <a:r>
-              <a:t>🎖️ VIP &amp; Speaker Profile:</a:t>
+              <a:t>🎖️ Featured Plenary Speakers:</a:t>
             </a:r>
           </a:p>
           <a:p>
@@ -12369,7 +12365,7 @@
               </a:defRPr>
             </a:pPr>
             <a:r>
-              <a:t>Municipal Tourism Officers (MTOs), Resort General Managers, Local Culinary Historians, and Senior Faculty Reactors.</a:t>
+              <a:t>Ms. Maria Luisa A. Elduayan (Coastal Eco-Tourism) and Felice Prudente Sta. Maria (Culinary Heritage Historian).</a:t>
             </a:r>
           </a:p>
           <a:p>
@@ -12385,7 +12381,7 @@
               </a:defRPr>
             </a:pPr>
             <a:r>
-              <a:t>📊 Capacity &amp; Volume:</a:t>
+              <a:t>📊 Panel &amp; Leadership:</a:t>
             </a:r>
           </a:p>
           <a:p>
@@ -12401,7 +12397,7 @@
               </a:defRPr>
             </a:pPr>
             <a:r>
-              <a:t>8–10 Invited Plenary Keynote Speakers, Panelists, and Reactors.</a:t>
+              <a:t>Event Chairpersons, CHTM Leads, Faculty Moderators, and Reactor Panel.</a:t>
             </a:r>
           </a:p>
           <a:p>
@@ -12433,19 +12429,15 @@
               </a:defRPr>
             </a:pPr>
             <a:r>
-              <a:t>• Strict program pacing and structured timing</a:t>
+              <a:t>• Strict 40-min talk + 25-min interactive Q&amp;A execution</a:t>
             </a:r>
             <a:br/>
             <a:r>
-              <a:t>• Clear stage AV, roving wireless mics, and confidence monitors</a:t>
+              <a:t>• Stage AV, podium mic, confidence monitors &amp; roving floor mics</a:t>
             </a:r>
             <a:br/>
             <a:r>
-              <a:t>• Dedicated VIP holding lounge with private plated catering</a:t>
-            </a:r>
-            <a:br/>
-            <a:r>
-              <a:t>• Formal honoraria, local tokens of appreciation, and plaques</a:t>
+              <a:t>• Dedicated VIP holding lounge, plated catering &amp; honoraria</a:t>
             </a:r>
           </a:p>
         </p:txBody>
@@ -12896,7 +12888,7 @@
               </a:defRPr>
             </a:pPr>
             <a:r>
-              <a:t>Host a regional academic conference featuring 3 keynote sessions and 4 student research panel presentations on Pangasinan tourism development and culinary heritage.</a:t>
+              <a:t>Host a high-impact regional conference featuring 2 master keynotes (Ms. Maria Luisa A. Elduayan &amp; Felice Prudente Sta. Maria) and an interactive synthesis session.</a:t>
             </a:r>
           </a:p>
         </p:txBody>
@@ -13046,7 +13038,7 @@
               </a:defRPr>
             </a:pPr>
             <a:r>
-              <a:t>Achieve attendance of at least 500 registered delegates and collect completed session feedback forms from at least 90% of attendees.</a:t>
+              <a:t>Achieve attendance of 500+ registered delegates and obtain completed digital feedback forms from at least 90% of attendees.</a:t>
             </a:r>
           </a:p>
         </p:txBody>
@@ -13196,7 +13188,7 @@
               </a:defRPr>
             </a:pPr>
             <a:r>
-              <a:t>Secure regional tourism officials and faculty experts as session speakers and panel reactors using the university's central facility.</a:t>
+              <a:t>Secure esteemed regional leaders and renowned culinary authors utilizing the university's central gymnasium facility.</a:t>
             </a:r>
           </a:p>
         </p:txBody>
@@ -13346,7 +13338,7 @@
               </a:defRPr>
             </a:pPr>
             <a:r>
-              <a:t>Fulfill BAM 205 conference management competencies including large-scale program structuring, speaker management, main-stage AV logistics, and delegate registration.</a:t>
+              <a:t>Fulfill BAM 205 conference management competencies including program structuring, AV staging, speaker relations, and delegate coordination.</a:t>
             </a:r>
           </a:p>
         </p:txBody>
@@ -13496,7 +13488,7 @@
               </a:defRPr>
             </a:pPr>
             <a:r>
-              <a:t>Execute the complete plenary schedule, panel sessions, open forum, and awarding ceremony within a 7-hour operational timeframe on September 17, 2026.</a:t>
+              <a:t>Execute the entire 11-segment plenary program smoothly from 8:00 AM to 12:00 NN on Thursday, September 17, 2026.</a:t>
             </a:r>
           </a:p>
         </p:txBody>
@@ -13963,7 +13955,7 @@
               </a:defRPr>
             </a:pPr>
             <a:r>
-              <a:t>⏰ Timeframe:</a:t>
+              <a:t>⏰ Operational Hours:</a:t>
             </a:r>
           </a:p>
           <a:p>
@@ -13979,7 +13971,7 @@
               </a:defRPr>
             </a:pPr>
             <a:r>
-              <a:t>8:30 AM – 3:30 PM (7 Hours Operational)</a:t>
+              <a:t>8:00 AM – 12:00 NN (Morning Plenary)</a:t>
             </a:r>
           </a:p>
           <a:p>
@@ -14649,7 +14641,7 @@
               </a:defRPr>
             </a:pPr>
             <a:r>
-              <a:t>SECTION 7 (PART 1) • SCHEDULE OF ACTIVITIES (08:30 AM – 12:00 PM)</a:t>
+              <a:t>SECTION 7 (PART 1) • SCHEDULE OF ACTIVITIES (08:00 AM – 10:05 AM)</a:t>
             </a:r>
           </a:p>
         </p:txBody>
@@ -14685,7 +14677,7 @@
               </a:defRPr>
             </a:pPr>
             <a:r>
-              <a:t>Program Flow: Morning Plenary Sessions</a:t>
+              <a:t>Program Flow: Part 1 — Opening &amp; Keynote 1</a:t>
             </a:r>
           </a:p>
         </p:txBody>
@@ -14778,8 +14770,8 @@
           <p:nvPr/>
         </p:nvGraphicFramePr>
         <p:xfrm>
-          <a:off x="731520" y="1371600"/>
-          <a:ext cx="10728655" cy="4754880"/>
+          <a:off x="731520" y="1325880"/>
+          <a:ext cx="10728655" cy="4846320"/>
         </p:xfrm>
         <a:graphic>
           <a:graphicData uri="http://schemas.openxmlformats.org/drawingml/2006/table">
@@ -14788,12 +14780,11 @@
                 <a:tableStyleId>{5C22544A-7EE6-4342-B048-85BDC9FD1C3A}</a:tableStyleId>
               </a:tblPr>
               <a:tblGrid>
-                <a:gridCol w="1828800"/>
-                <a:gridCol w="2926080"/>
-                <a:gridCol w="3840480"/>
-                <a:gridCol w="2133295"/>
+                <a:gridCol w="2011680"/>
+                <a:gridCol w="5943600"/>
+                <a:gridCol w="2773375"/>
               </a:tblGrid>
-              <a:tr h="792480">
+              <a:tr h="692331">
                 <a:tc>
                   <a:txBody>
                     <a:bodyPr/>
@@ -14832,7 +14823,7 @@
                         </a:defRPr>
                       </a:pPr>
                       <a:r>
-                        <a:t>Session Title</a:t>
+                        <a:t>Activity / Session Title</a:t>
                       </a:r>
                     </a:p>
                   </a:txBody>
@@ -14856,31 +14847,7 @@
                         </a:defRPr>
                       </a:pPr>
                       <a:r>
-                        <a:t>Description / Content</a:t>
-                      </a:r>
-                    </a:p>
-                  </a:txBody>
-                  <a:tcPr>
-                    <a:solidFill>
-                      <a:srgbClr val="1B4332"/>
-                    </a:solidFill>
-                  </a:tcPr>
-                </a:tc>
-                <a:tc>
-                  <a:txBody>
-                    <a:bodyPr/>
-                    <a:lstStyle/>
-                    <a:p>
-                      <a:pPr>
-                        <a:defRPr b="1" sz="1100">
-                          <a:solidFill>
-                            <a:srgbClr val="D4AF37"/>
-                          </a:solidFill>
-                          <a:latin typeface="Arial"/>
-                        </a:defRPr>
-                      </a:pPr>
-                      <a:r>
-                        <a:t>Person / Group in Charge</a:t>
+                        <a:t>Facilitator / Lead</a:t>
                       </a:r>
                     </a:p>
                   </a:txBody>
@@ -14891,14 +14858,14 @@
                   </a:tcPr>
                 </a:tc>
               </a:tr>
-              <a:tr h="792480">
+              <a:tr h="692331">
                 <a:tc>
                   <a:txBody>
                     <a:bodyPr/>
                     <a:lstStyle/>
                     <a:p>
                       <a:pPr>
-                        <a:defRPr sz="1000" b="1">
+                        <a:defRPr sz="950" b="1">
                           <a:solidFill>
                             <a:srgbClr val="1B4332"/>
                           </a:solidFill>
@@ -14906,7 +14873,7 @@
                         </a:defRPr>
                       </a:pPr>
                       <a:r>
-                        <a:t>08:30 AM – 09:00 AM</a:t>
+                        <a:t>8:00 AM – 8:30 AM</a:t>
                       </a:r>
                     </a:p>
                   </a:txBody>
@@ -14922,7 +14889,7 @@
                     <a:lstStyle/>
                     <a:p>
                       <a:pPr>
-                        <a:defRPr sz="1000" b="1">
+                        <a:defRPr sz="950">
                           <a:solidFill>
                             <a:srgbClr val="1E2923"/>
                           </a:solidFill>
@@ -14930,7 +14897,12 @@
                         </a:defRPr>
                       </a:pPr>
                       <a:r>
-                        <a:t>Delegate Registration &amp; Kit Distribution</a:t>
+                        <a:t>On-Site Check-In &amp; Name Tag Distribution</a:t>
+                      </a:r>
+                    </a:p>
+                    <a:p>
+                      <a:r>
+                        <a:t>Registration desks open at Gym foyer with kit issuance.</a:t>
                       </a:r>
                     </a:p>
                   </a:txBody>
@@ -14946,7 +14918,7 @@
                     <a:lstStyle/>
                     <a:p>
                       <a:pPr>
-                        <a:defRPr sz="1000">
+                        <a:defRPr sz="950">
                           <a:solidFill>
                             <a:srgbClr val="1E2923"/>
                           </a:solidFill>
@@ -14954,7 +14926,112 @@
                         </a:defRPr>
                       </a:pPr>
                       <a:r>
-                        <a:t>Sign-in at Gym foyer registration desks; distribution of conference badges, notepad kits, and session programs.</a:t>
+                        <a:t>Registration Committee</a:t>
+                      </a:r>
+                    </a:p>
+                  </a:txBody>
+                  <a:tcPr>
+                    <a:solidFill>
+                      <a:srgbClr val="FFFFFF"/>
+                    </a:solidFill>
+                  </a:tcPr>
+                </a:tc>
+              </a:tr>
+              <a:tr h="692331">
+                <a:tc>
+                  <a:txBody>
+                    <a:bodyPr/>
+                    <a:lstStyle/>
+                    <a:p>
+                      <a:pPr>
+                        <a:defRPr sz="950" b="1">
+                          <a:solidFill>
+                            <a:srgbClr val="1B4332"/>
+                          </a:solidFill>
+                          <a:latin typeface="Arial"/>
+                        </a:defRPr>
+                      </a:pPr>
+                      <a:r>
+                        <a:t>8:30 AM – 8:40 AM</a:t>
+                      </a:r>
+                    </a:p>
+                  </a:txBody>
+                  <a:tcPr>
+                    <a:solidFill>
+                      <a:srgbClr val="F8F9FA"/>
+                    </a:solidFill>
+                  </a:tcPr>
+                </a:tc>
+                <a:tc>
+                  <a:txBody>
+                    <a:bodyPr/>
+                    <a:lstStyle/>
+                    <a:p>
+                      <a:pPr>
+                        <a:defRPr sz="950">
+                          <a:solidFill>
+                            <a:srgbClr val="1E2923"/>
+                          </a:solidFill>
+                          <a:latin typeface="Arial"/>
+                        </a:defRPr>
+                      </a:pPr>
+                      <a:r>
+                        <a:t>Doxology &amp; National Anthem</a:t>
+                      </a:r>
+                    </a:p>
+                    <a:p>
+                      <a:r>
+                        <a:t>Formal invocation and Philippine National Anthem.</a:t>
+                      </a:r>
+                    </a:p>
+                  </a:txBody>
+                  <a:tcPr>
+                    <a:solidFill>
+                      <a:srgbClr val="F8F9FA"/>
+                    </a:solidFill>
+                  </a:tcPr>
+                </a:tc>
+                <a:tc>
+                  <a:txBody>
+                    <a:bodyPr/>
+                    <a:lstStyle/>
+                    <a:p>
+                      <a:pPr>
+                        <a:defRPr sz="950">
+                          <a:solidFill>
+                            <a:srgbClr val="1E2923"/>
+                          </a:solidFill>
+                          <a:latin typeface="Arial"/>
+                        </a:defRPr>
+                      </a:pPr>
+                      <a:r>
+                        <a:t>Program Committee</a:t>
+                      </a:r>
+                    </a:p>
+                  </a:txBody>
+                  <a:tcPr>
+                    <a:solidFill>
+                      <a:srgbClr val="F8F9FA"/>
+                    </a:solidFill>
+                  </a:tcPr>
+                </a:tc>
+              </a:tr>
+              <a:tr h="692331">
+                <a:tc>
+                  <a:txBody>
+                    <a:bodyPr/>
+                    <a:lstStyle/>
+                    <a:p>
+                      <a:pPr>
+                        <a:defRPr sz="950" b="1">
+                          <a:solidFill>
+                            <a:srgbClr val="1B4332"/>
+                          </a:solidFill>
+                          <a:latin typeface="Arial"/>
+                        </a:defRPr>
+                      </a:pPr>
+                      <a:r>
+                        <a:t>8:40 AM – 8:50 AM</a:t>
                       </a:r>
                     </a:p>
                   </a:txBody>
@@ -14970,7 +15047,7 @@
                     <a:lstStyle/>
                     <a:p>
                       <a:pPr>
-                        <a:defRPr sz="1000">
+                        <a:defRPr sz="950">
                           <a:solidFill>
                             <a:srgbClr val="1E2923"/>
                           </a:solidFill>
@@ -14978,7 +15055,36 @@
                         </a:defRPr>
                       </a:pPr>
                       <a:r>
-                        <a:t>Secretariat &amp; Registration Team</a:t>
+                        <a:t>Welcome Address</a:t>
+                      </a:r>
+                    </a:p>
+                    <a:p>
+                      <a:r>
+                        <a:t>Opening institutional remarks welcoming delegates and guests.</a:t>
+                      </a:r>
+                    </a:p>
+                  </a:txBody>
+                  <a:tcPr>
+                    <a:solidFill>
+                      <a:srgbClr val="FFFFFF"/>
+                    </a:solidFill>
+                  </a:tcPr>
+                </a:tc>
+                <a:tc>
+                  <a:txBody>
+                    <a:bodyPr/>
+                    <a:lstStyle/>
+                    <a:p>
+                      <a:pPr>
+                        <a:defRPr sz="950">
+                          <a:solidFill>
+                            <a:srgbClr val="1E2923"/>
+                          </a:solidFill>
+                          <a:latin typeface="Arial"/>
+                        </a:defRPr>
+                      </a:pPr>
+                      <a:r>
+                        <a:t>Event Chairperson / CHTM Lead</a:t>
                       </a:r>
                     </a:p>
                   </a:txBody>
@@ -14989,14 +15095,14 @@
                   </a:tcPr>
                 </a:tc>
               </a:tr>
-              <a:tr h="792480">
+              <a:tr h="692331">
                 <a:tc>
                   <a:txBody>
                     <a:bodyPr/>
                     <a:lstStyle/>
                     <a:p>
                       <a:pPr>
-                        <a:defRPr sz="1000" b="1">
+                        <a:defRPr sz="950" b="1">
                           <a:solidFill>
                             <a:srgbClr val="1B4332"/>
                           </a:solidFill>
@@ -15004,7 +15110,7 @@
                         </a:defRPr>
                       </a:pPr>
                       <a:r>
-                        <a:t>09:00 AM – 09:30 AM</a:t>
+                        <a:t>8:50 AM – 9:00 AM</a:t>
                       </a:r>
                     </a:p>
                   </a:txBody>
@@ -15020,7 +15126,7 @@
                     <a:lstStyle/>
                     <a:p>
                       <a:pPr>
-                        <a:defRPr sz="1000" b="1">
+                        <a:defRPr sz="950">
                           <a:solidFill>
                             <a:srgbClr val="1E2923"/>
                           </a:solidFill>
@@ -15028,7 +15134,12 @@
                         </a:defRPr>
                       </a:pPr>
                       <a:r>
-                        <a:t>Opening Plenary &amp; Welcome Address</a:t>
+                        <a:t>Opening Remarks &amp; Speaker Introduction</a:t>
+                      </a:r>
+                    </a:p>
+                    <a:p>
+                      <a:r>
+                        <a:t>Contextual overview of PECS 2026 &amp; formal speaker citation.</a:t>
                       </a:r>
                     </a:p>
                   </a:txBody>
@@ -15044,7 +15155,7 @@
                     <a:lstStyle/>
                     <a:p>
                       <a:pPr>
-                        <a:defRPr sz="1000">
+                        <a:defRPr sz="950">
                           <a:solidFill>
                             <a:srgbClr val="1E2923"/>
                           </a:solidFill>
@@ -15052,7 +15163,112 @@
                         </a:defRPr>
                       </a:pPr>
                       <a:r>
-                        <a:t>Doxology, National Anthem, and Opening Remarks by CHTM Leadership.</a:t>
+                        <a:t>Master of Ceremonies</a:t>
+                      </a:r>
+                    </a:p>
+                  </a:txBody>
+                  <a:tcPr>
+                    <a:solidFill>
+                      <a:srgbClr val="F8F9FA"/>
+                    </a:solidFill>
+                  </a:tcPr>
+                </a:tc>
+              </a:tr>
+              <a:tr h="692331">
+                <a:tc>
+                  <a:txBody>
+                    <a:bodyPr/>
+                    <a:lstStyle/>
+                    <a:p>
+                      <a:pPr>
+                        <a:defRPr sz="950" b="1">
+                          <a:solidFill>
+                            <a:srgbClr val="1B4332"/>
+                          </a:solidFill>
+                          <a:latin typeface="Arial"/>
+                        </a:defRPr>
+                      </a:pPr>
+                      <a:r>
+                        <a:t>9:00 AM – 9:40 AM</a:t>
+                      </a:r>
+                    </a:p>
+                  </a:txBody>
+                  <a:tcPr>
+                    <a:solidFill>
+                      <a:srgbClr val="FFFFFF"/>
+                    </a:solidFill>
+                  </a:tcPr>
+                </a:tc>
+                <a:tc>
+                  <a:txBody>
+                    <a:bodyPr/>
+                    <a:lstStyle/>
+                    <a:p>
+                      <a:pPr>
+                        <a:defRPr sz="950" b="1">
+                          <a:solidFill>
+                            <a:srgbClr val="1B4332"/>
+                          </a:solidFill>
+                          <a:latin typeface="Arial"/>
+                        </a:defRPr>
+                      </a:pPr>
+                      <a:r>
+                        <a:t>Keynote 1: “Protecting Pangasinan’s Shorelines: Sustainable Eco-Tourism Strategies and Carrying Capacity in Coastal Destinations”</a:t>
+                      </a:r>
+                    </a:p>
+                  </a:txBody>
+                  <a:tcPr>
+                    <a:solidFill>
+                      <a:srgbClr val="FFFFFF"/>
+                    </a:solidFill>
+                  </a:tcPr>
+                </a:tc>
+                <a:tc>
+                  <a:txBody>
+                    <a:bodyPr/>
+                    <a:lstStyle/>
+                    <a:p>
+                      <a:pPr>
+                        <a:defRPr sz="950">
+                          <a:solidFill>
+                            <a:srgbClr val="1E2923"/>
+                          </a:solidFill>
+                          <a:latin typeface="Arial"/>
+                        </a:defRPr>
+                      </a:pPr>
+                      <a:r>
+                        <a:t>Ms. Maria Luisa A. Elduayan</a:t>
+                      </a:r>
+                    </a:p>
+                    <a:p>
+                      <a:r>
+                        <a:t>(Provincial Tourism Officer)</a:t>
+                      </a:r>
+                    </a:p>
+                  </a:txBody>
+                  <a:tcPr>
+                    <a:solidFill>
+                      <a:srgbClr val="FFFFFF"/>
+                    </a:solidFill>
+                  </a:tcPr>
+                </a:tc>
+              </a:tr>
+              <a:tr h="692334">
+                <a:tc>
+                  <a:txBody>
+                    <a:bodyPr/>
+                    <a:lstStyle/>
+                    <a:p>
+                      <a:pPr>
+                        <a:defRPr sz="950" b="1">
+                          <a:solidFill>
+                            <a:srgbClr val="1B4332"/>
+                          </a:solidFill>
+                          <a:latin typeface="Arial"/>
+                        </a:defRPr>
+                      </a:pPr>
+                      <a:r>
+                        <a:t>9:40 AM – 10:05 AM</a:t>
                       </a:r>
                     </a:p>
                   </a:txBody>
@@ -15068,7 +15284,7 @@
                     <a:lstStyle/>
                     <a:p>
                       <a:pPr>
-                        <a:defRPr sz="1000">
+                        <a:defRPr sz="950">
                           <a:solidFill>
                             <a:srgbClr val="1E2923"/>
                           </a:solidFill>
@@ -15076,131 +15292,12 @@
                         </a:defRPr>
                       </a:pPr>
                       <a:r>
-                        <a:t>Conference Master of Ceremonies</a:t>
+                        <a:t>Interactive Q&amp;A Session</a:t>
                       </a:r>
                     </a:p>
-                  </a:txBody>
-                  <a:tcPr>
-                    <a:solidFill>
-                      <a:srgbClr val="F8F9FA"/>
-                    </a:solidFill>
-                  </a:tcPr>
-                </a:tc>
-              </a:tr>
-              <a:tr h="792480">
-                <a:tc>
-                  <a:txBody>
-                    <a:bodyPr/>
-                    <a:lstStyle/>
                     <a:p>
-                      <a:pPr>
-                        <a:defRPr sz="1000" b="1">
-                          <a:solidFill>
-                            <a:srgbClr val="1B4332"/>
-                          </a:solidFill>
-                          <a:latin typeface="Arial"/>
-                        </a:defRPr>
-                      </a:pPr>
                       <a:r>
-                        <a:t>09:30 AM – 10:30 AM</a:t>
-                      </a:r>
-                    </a:p>
-                  </a:txBody>
-                  <a:tcPr>
-                    <a:solidFill>
-                      <a:srgbClr val="FFFFFF"/>
-                    </a:solidFill>
-                  </a:tcPr>
-                </a:tc>
-                <a:tc>
-                  <a:txBody>
-                    <a:bodyPr/>
-                    <a:lstStyle/>
-                    <a:p>
-                      <a:pPr>
-                        <a:defRPr sz="1000" b="1">
-                          <a:solidFill>
-                            <a:srgbClr val="1E2923"/>
-                          </a:solidFill>
-                          <a:latin typeface="Arial"/>
-                        </a:defRPr>
-                      </a:pPr>
-                      <a:r>
-                        <a:t>Keynote 1: Coastal Eco-Tourism Frameworks</a:t>
-                      </a:r>
-                    </a:p>
-                  </a:txBody>
-                  <a:tcPr>
-                    <a:solidFill>
-                      <a:srgbClr val="FFFFFF"/>
-                    </a:solidFill>
-                  </a:tcPr>
-                </a:tc>
-                <a:tc>
-                  <a:txBody>
-                    <a:bodyPr/>
-                    <a:lstStyle/>
-                    <a:p>
-                      <a:pPr>
-                        <a:defRPr sz="1000">
-                          <a:solidFill>
-                            <a:srgbClr val="1E2923"/>
-                          </a:solidFill>
-                          <a:latin typeface="Arial"/>
-                        </a:defRPr>
-                      </a:pPr>
-                      <a:r>
-                        <a:t>Presentation on sustainable destination management across Pangasinan municipalities.</a:t>
-                      </a:r>
-                    </a:p>
-                  </a:txBody>
-                  <a:tcPr>
-                    <a:solidFill>
-                      <a:srgbClr val="FFFFFF"/>
-                    </a:solidFill>
-                  </a:tcPr>
-                </a:tc>
-                <a:tc>
-                  <a:txBody>
-                    <a:bodyPr/>
-                    <a:lstStyle/>
-                    <a:p>
-                      <a:pPr>
-                        <a:defRPr sz="1000">
-                          <a:solidFill>
-                            <a:srgbClr val="1E2923"/>
-                          </a:solidFill>
-                          <a:latin typeface="Arial"/>
-                        </a:defRPr>
-                      </a:pPr>
-                      <a:r>
-                        <a:t>Invited Municipal Tourism Officer</a:t>
-                      </a:r>
-                    </a:p>
-                  </a:txBody>
-                  <a:tcPr>
-                    <a:solidFill>
-                      <a:srgbClr val="FFFFFF"/>
-                    </a:solidFill>
-                  </a:tcPr>
-                </a:tc>
-              </a:tr>
-              <a:tr h="792480">
-                <a:tc>
-                  <a:txBody>
-                    <a:bodyPr/>
-                    <a:lstStyle/>
-                    <a:p>
-                      <a:pPr>
-                        <a:defRPr sz="1000" b="1">
-                          <a:solidFill>
-                            <a:srgbClr val="1B4332"/>
-                          </a:solidFill>
-                          <a:latin typeface="Arial"/>
-                        </a:defRPr>
-                      </a:pPr>
-                      <a:r>
-                        <a:t>10:30 AM – 11:30 AM</a:t>
+                        <a:t>Floor microphones open for delegate inquiries to Keynote 1.</a:t>
                       </a:r>
                     </a:p>
                   </a:txBody>
@@ -15216,7 +15313,7 @@
                     <a:lstStyle/>
                     <a:p>
                       <a:pPr>
-                        <a:defRPr sz="1000" b="1">
+                        <a:defRPr sz="950">
                           <a:solidFill>
                             <a:srgbClr val="1E2923"/>
                           </a:solidFill>
@@ -15224,159 +15321,13 @@
                         </a:defRPr>
                       </a:pPr>
                       <a:r>
-                        <a:t>Keynote 2: Preserving Heritage Flavor Profiles</a:t>
+                        <a:t>Moderator &amp; Delegates</a:t>
                       </a:r>
                     </a:p>
                   </a:txBody>
                   <a:tcPr>
                     <a:solidFill>
                       <a:srgbClr val="F8F9FA"/>
-                    </a:solidFill>
-                  </a:tcPr>
-                </a:tc>
-                <a:tc>
-                  <a:txBody>
-                    <a:bodyPr/>
-                    <a:lstStyle/>
-                    <a:p>
-                      <a:pPr>
-                        <a:defRPr sz="1000">
-                          <a:solidFill>
-                            <a:srgbClr val="1E2923"/>
-                          </a:solidFill>
-                          <a:latin typeface="Arial"/>
-                        </a:defRPr>
-                      </a:pPr>
-                      <a:r>
-                        <a:t>Industry talk on preserving regional culinary recipes and integrating them into modern hospitality.</a:t>
-                      </a:r>
-                    </a:p>
-                  </a:txBody>
-                  <a:tcPr>
-                    <a:solidFill>
-                      <a:srgbClr val="F8F9FA"/>
-                    </a:solidFill>
-                  </a:tcPr>
-                </a:tc>
-                <a:tc>
-                  <a:txBody>
-                    <a:bodyPr/>
-                    <a:lstStyle/>
-                    <a:p>
-                      <a:pPr>
-                        <a:defRPr sz="1000">
-                          <a:solidFill>
-                            <a:srgbClr val="1E2923"/>
-                          </a:solidFill>
-                          <a:latin typeface="Arial"/>
-                        </a:defRPr>
-                      </a:pPr>
-                      <a:r>
-                        <a:t>Guest Chef / Culinary Historian</a:t>
-                      </a:r>
-                    </a:p>
-                  </a:txBody>
-                  <a:tcPr>
-                    <a:solidFill>
-                      <a:srgbClr val="F8F9FA"/>
-                    </a:solidFill>
-                  </a:tcPr>
-                </a:tc>
-              </a:tr>
-              <a:tr h="792480">
-                <a:tc>
-                  <a:txBody>
-                    <a:bodyPr/>
-                    <a:lstStyle/>
-                    <a:p>
-                      <a:pPr>
-                        <a:defRPr sz="1000" b="1">
-                          <a:solidFill>
-                            <a:srgbClr val="1B4332"/>
-                          </a:solidFill>
-                          <a:latin typeface="Arial"/>
-                        </a:defRPr>
-                      </a:pPr>
-                      <a:r>
-                        <a:t>11:30 AM – 12:00 PM</a:t>
-                      </a:r>
-                    </a:p>
-                  </a:txBody>
-                  <a:tcPr>
-                    <a:solidFill>
-                      <a:srgbClr val="FFFFFF"/>
-                    </a:solidFill>
-                  </a:tcPr>
-                </a:tc>
-                <a:tc>
-                  <a:txBody>
-                    <a:bodyPr/>
-                    <a:lstStyle/>
-                    <a:p>
-                      <a:pPr>
-                        <a:defRPr sz="1000" b="1">
-                          <a:solidFill>
-                            <a:srgbClr val="1E2923"/>
-                          </a:solidFill>
-                          <a:latin typeface="Arial"/>
-                        </a:defRPr>
-                      </a:pPr>
-                      <a:r>
-                        <a:t>Open Forum &amp; Delegate Q&amp;A</a:t>
-                      </a:r>
-                    </a:p>
-                  </a:txBody>
-                  <a:tcPr>
-                    <a:solidFill>
-                      <a:srgbClr val="FFFFFF"/>
-                    </a:solidFill>
-                  </a:tcPr>
-                </a:tc>
-                <a:tc>
-                  <a:txBody>
-                    <a:bodyPr/>
-                    <a:lstStyle/>
-                    <a:p>
-                      <a:pPr>
-                        <a:defRPr sz="1000">
-                          <a:solidFill>
-                            <a:srgbClr val="1E2923"/>
-                          </a:solidFill>
-                          <a:latin typeface="Arial"/>
-                        </a:defRPr>
-                      </a:pPr>
-                      <a:r>
-                        <a:t>Floor microphones open for delegate inquiries directed to Keynote Speakers 1 and 2.</a:t>
-                      </a:r>
-                    </a:p>
-                  </a:txBody>
-                  <a:tcPr>
-                    <a:solidFill>
-                      <a:srgbClr val="FFFFFF"/>
-                    </a:solidFill>
-                  </a:tcPr>
-                </a:tc>
-                <a:tc>
-                  <a:txBody>
-                    <a:bodyPr/>
-                    <a:lstStyle/>
-                    <a:p>
-                      <a:pPr>
-                        <a:defRPr sz="1000">
-                          <a:solidFill>
-                            <a:srgbClr val="1E2923"/>
-                          </a:solidFill>
-                          <a:latin typeface="Arial"/>
-                        </a:defRPr>
-                      </a:pPr>
-                      <a:r>
-                        <a:t>Stage Moderator</a:t>
-                      </a:r>
-                    </a:p>
-                  </a:txBody>
-                  <a:tcPr>
-                    <a:solidFill>
-                      <a:srgbClr val="FFFFFF"/>
                     </a:solidFill>
                   </a:tcPr>
                 </a:tc>
@@ -15566,7 +15517,7 @@
               </a:defRPr>
             </a:pPr>
             <a:r>
-              <a:t>SECTION 7 (PART 2) • SCHEDULE OF ACTIVITIES (12:00 PM – 03:30 PM)</a:t>
+              <a:t>SECTION 7 (PART 2) • SCHEDULE OF ACTIVITIES (10:05 AM – 12:00 NN)</a:t>
             </a:r>
           </a:p>
         </p:txBody>
@@ -15602,7 +15553,7 @@
               </a:defRPr>
             </a:pPr>
             <a:r>
-              <a:t>Program Flow: Afternoon Colloquium &amp; Closing</a:t>
+              <a:t>Program Flow: Part 2 — Keynote 2, Synthesis &amp; Closing</a:t>
             </a:r>
           </a:p>
         </p:txBody>
@@ -15695,8 +15646,8 @@
           <p:nvPr/>
         </p:nvGraphicFramePr>
         <p:xfrm>
-          <a:off x="731520" y="1371600"/>
-          <a:ext cx="10728655" cy="3931920"/>
+          <a:off x="731520" y="1325880"/>
+          <a:ext cx="10728655" cy="4114800"/>
         </p:xfrm>
         <a:graphic>
           <a:graphicData uri="http://schemas.openxmlformats.org/drawingml/2006/table">
@@ -15705,12 +15656,11 @@
                 <a:tableStyleId>{5C22544A-7EE6-4342-B048-85BDC9FD1C3A}</a:tableStyleId>
               </a:tblPr>
               <a:tblGrid>
-                <a:gridCol w="1828800"/>
-                <a:gridCol w="2926080"/>
-                <a:gridCol w="3840480"/>
-                <a:gridCol w="2133295"/>
+                <a:gridCol w="2011680"/>
+                <a:gridCol w="5943600"/>
+                <a:gridCol w="2773375"/>
               </a:tblGrid>
-              <a:tr h="786384">
+              <a:tr h="685800">
                 <a:tc>
                   <a:txBody>
                     <a:bodyPr/>
@@ -15749,7 +15699,7 @@
                         </a:defRPr>
                       </a:pPr>
                       <a:r>
-                        <a:t>Session Title</a:t>
+                        <a:t>Activity / Session Title</a:t>
                       </a:r>
                     </a:p>
                   </a:txBody>
@@ -15773,31 +15723,7 @@
                         </a:defRPr>
                       </a:pPr>
                       <a:r>
-                        <a:t>Description / Content</a:t>
-                      </a:r>
-                    </a:p>
-                  </a:txBody>
-                  <a:tcPr>
-                    <a:solidFill>
-                      <a:srgbClr val="1B4332"/>
-                    </a:solidFill>
-                  </a:tcPr>
-                </a:tc>
-                <a:tc>
-                  <a:txBody>
-                    <a:bodyPr/>
-                    <a:lstStyle/>
-                    <a:p>
-                      <a:pPr>
-                        <a:defRPr b="1" sz="1100">
-                          <a:solidFill>
-                            <a:srgbClr val="D4AF37"/>
-                          </a:solidFill>
-                          <a:latin typeface="Arial"/>
-                        </a:defRPr>
-                      </a:pPr>
-                      <a:r>
-                        <a:t>Person / Group in Charge</a:t>
+                        <a:t>Facilitator / Lead</a:t>
                       </a:r>
                     </a:p>
                   </a:txBody>
@@ -15808,14 +15734,14 @@
                   </a:tcPr>
                 </a:tc>
               </a:tr>
-              <a:tr h="786384">
+              <a:tr h="685800">
                 <a:tc>
                   <a:txBody>
                     <a:bodyPr/>
                     <a:lstStyle/>
                     <a:p>
                       <a:pPr>
-                        <a:defRPr sz="1000" b="1">
+                        <a:defRPr sz="950" b="1">
                           <a:solidFill>
                             <a:srgbClr val="1B4332"/>
                           </a:solidFill>
@@ -15823,7 +15749,7 @@
                         </a:defRPr>
                       </a:pPr>
                       <a:r>
-                        <a:t>12:00 PM – 01:00 PM</a:t>
+                        <a:t>10:05 AM – 10:45 AM</a:t>
                       </a:r>
                     </a:p>
                   </a:txBody>
@@ -15839,15 +15765,15 @@
                     <a:lstStyle/>
                     <a:p>
                       <a:pPr>
-                        <a:defRPr sz="1000" b="1">
+                        <a:defRPr sz="950" b="1">
                           <a:solidFill>
-                            <a:srgbClr val="1E2923"/>
+                            <a:srgbClr val="1B4332"/>
                           </a:solidFill>
                           <a:latin typeface="Arial"/>
                         </a:defRPr>
                       </a:pPr>
                       <a:r>
-                        <a:t>Lunch Break &amp; Networking</a:t>
+                        <a:t>Keynote 2: “From Coastal Waters to Heritage Plates: Preserving Pangasinan’s Culinary Identity in Modern Gastronomy Tourism”</a:t>
                       </a:r>
                     </a:p>
                   </a:txBody>
@@ -15863,7 +15789,7 @@
                     <a:lstStyle/>
                     <a:p>
                       <a:pPr>
-                        <a:defRPr sz="1000">
+                        <a:defRPr sz="950">
                           <a:solidFill>
                             <a:srgbClr val="1E2923"/>
                           </a:solidFill>
@@ -15871,7 +15797,117 @@
                         </a:defRPr>
                       </a:pPr>
                       <a:r>
-                        <a:t>Networking lunch for delegates; VIP dining in the designated Gym VIP Lounge.</a:t>
+                        <a:t>Felice Prudente Sta. Maria</a:t>
+                      </a:r>
+                    </a:p>
+                    <a:p>
+                      <a:r>
+                        <a:t>(Culinary Historian &amp; Author)</a:t>
+                      </a:r>
+                    </a:p>
+                  </a:txBody>
+                  <a:tcPr>
+                    <a:solidFill>
+                      <a:srgbClr val="FFFFFF"/>
+                    </a:solidFill>
+                  </a:tcPr>
+                </a:tc>
+              </a:tr>
+              <a:tr h="685800">
+                <a:tc>
+                  <a:txBody>
+                    <a:bodyPr/>
+                    <a:lstStyle/>
+                    <a:p>
+                      <a:pPr>
+                        <a:defRPr sz="950" b="1">
+                          <a:solidFill>
+                            <a:srgbClr val="1B4332"/>
+                          </a:solidFill>
+                          <a:latin typeface="Arial"/>
+                        </a:defRPr>
+                      </a:pPr>
+                      <a:r>
+                        <a:t>10:45 AM – 11:10 AM</a:t>
+                      </a:r>
+                    </a:p>
+                  </a:txBody>
+                  <a:tcPr>
+                    <a:solidFill>
+                      <a:srgbClr val="F8F9FA"/>
+                    </a:solidFill>
+                  </a:tcPr>
+                </a:tc>
+                <a:tc>
+                  <a:txBody>
+                    <a:bodyPr/>
+                    <a:lstStyle/>
+                    <a:p>
+                      <a:pPr>
+                        <a:defRPr sz="950">
+                          <a:solidFill>
+                            <a:srgbClr val="1E2923"/>
+                          </a:solidFill>
+                          <a:latin typeface="Arial"/>
+                        </a:defRPr>
+                      </a:pPr>
+                      <a:r>
+                        <a:t>Interactive Q&amp;A Session</a:t>
+                      </a:r>
+                    </a:p>
+                    <a:p>
+                      <a:r>
+                        <a:t>Open floor exchange and discussions with Keynote 2.</a:t>
+                      </a:r>
+                    </a:p>
+                  </a:txBody>
+                  <a:tcPr>
+                    <a:solidFill>
+                      <a:srgbClr val="F8F9FA"/>
+                    </a:solidFill>
+                  </a:tcPr>
+                </a:tc>
+                <a:tc>
+                  <a:txBody>
+                    <a:bodyPr/>
+                    <a:lstStyle/>
+                    <a:p>
+                      <a:pPr>
+                        <a:defRPr sz="950">
+                          <a:solidFill>
+                            <a:srgbClr val="1E2923"/>
+                          </a:solidFill>
+                          <a:latin typeface="Arial"/>
+                        </a:defRPr>
+                      </a:pPr>
+                      <a:r>
+                        <a:t>Moderator &amp; Delegates</a:t>
+                      </a:r>
+                    </a:p>
+                  </a:txBody>
+                  <a:tcPr>
+                    <a:solidFill>
+                      <a:srgbClr val="F8F9FA"/>
+                    </a:solidFill>
+                  </a:tcPr>
+                </a:tc>
+              </a:tr>
+              <a:tr h="685800">
+                <a:tc>
+                  <a:txBody>
+                    <a:bodyPr/>
+                    <a:lstStyle/>
+                    <a:p>
+                      <a:pPr>
+                        <a:defRPr sz="950" b="1">
+                          <a:solidFill>
+                            <a:srgbClr val="1B4332"/>
+                          </a:solidFill>
+                          <a:latin typeface="Arial"/>
+                        </a:defRPr>
+                      </a:pPr>
+                      <a:r>
+                        <a:t>11:10 AM – 11:40 AM</a:t>
                       </a:r>
                     </a:p>
                   </a:txBody>
@@ -15887,7 +15923,7 @@
                     <a:lstStyle/>
                     <a:p>
                       <a:pPr>
-                        <a:defRPr sz="1000">
+                        <a:defRPr sz="950">
                           <a:solidFill>
                             <a:srgbClr val="1E2923"/>
                           </a:solidFill>
@@ -15895,7 +15931,36 @@
                         </a:defRPr>
                       </a:pPr>
                       <a:r>
-                        <a:t>Logistics &amp; Catering Team</a:t>
+                        <a:t>Synthesis Session: Aligning Eco-Tourism with Local Food Systems</a:t>
+                      </a:r>
+                    </a:p>
+                    <a:p>
+                      <a:r>
+                        <a:t>Consolidating policy, hospitality practices, and research outputs.</a:t>
+                      </a:r>
+                    </a:p>
+                  </a:txBody>
+                  <a:tcPr>
+                    <a:solidFill>
+                      <a:srgbClr val="FFFFFF"/>
+                    </a:solidFill>
+                  </a:tcPr>
+                </a:tc>
+                <a:tc>
+                  <a:txBody>
+                    <a:bodyPr/>
+                    <a:lstStyle/>
+                    <a:p>
+                      <a:pPr>
+                        <a:defRPr sz="950">
+                          <a:solidFill>
+                            <a:srgbClr val="1E2923"/>
+                          </a:solidFill>
+                          <a:latin typeface="Arial"/>
+                        </a:defRPr>
+                      </a:pPr>
+                      <a:r>
+                        <a:t>CHTM Faculty Moderator</a:t>
                       </a:r>
                     </a:p>
                   </a:txBody>
@@ -15906,14 +15971,14 @@
                   </a:tcPr>
                 </a:tc>
               </a:tr>
-              <a:tr h="786384">
+              <a:tr h="685800">
                 <a:tc>
                   <a:txBody>
                     <a:bodyPr/>
                     <a:lstStyle/>
                     <a:p>
                       <a:pPr>
-                        <a:defRPr sz="1000" b="1">
+                        <a:defRPr sz="950" b="1">
                           <a:solidFill>
                             <a:srgbClr val="1B4332"/>
                           </a:solidFill>
@@ -15921,7 +15986,7 @@
                         </a:defRPr>
                       </a:pPr>
                       <a:r>
-                        <a:t>01:00 PM – 02:30 PM</a:t>
+                        <a:t>11:40 AM – 11:50 AM</a:t>
                       </a:r>
                     </a:p>
                   </a:txBody>
@@ -15937,7 +16002,7 @@
                     <a:lstStyle/>
                     <a:p>
                       <a:pPr>
-                        <a:defRPr sz="1000" b="1">
+                        <a:defRPr sz="950">
                           <a:solidFill>
                             <a:srgbClr val="1E2923"/>
                           </a:solidFill>
@@ -15945,7 +16010,12 @@
                         </a:defRPr>
                       </a:pPr>
                       <a:r>
-                        <a:t>Panel Session: Student Research Colloquium</a:t>
+                        <a:t>Presentation of Tokens &amp; Certificates to Speakers</a:t>
+                      </a:r>
+                    </a:p>
+                    <a:p>
+                      <a:r>
+                        <a:t>Conferment of Plaques of Appreciation and gift baskets.</a:t>
                       </a:r>
                     </a:p>
                   </a:txBody>
@@ -15961,7 +16031,7 @@
                     <a:lstStyle/>
                     <a:p>
                       <a:pPr>
-                        <a:defRPr sz="1000">
+                        <a:defRPr sz="950">
                           <a:solidFill>
                             <a:srgbClr val="1E2923"/>
                           </a:solidFill>
@@ -15969,31 +16039,7 @@
                         </a:defRPr>
                       </a:pPr>
                       <a:r>
-                        <a:t>Oral presentations of 4 selected student research papers on local resort models and eco-tourism.</a:t>
-                      </a:r>
-                    </a:p>
-                  </a:txBody>
-                  <a:tcPr>
-                    <a:solidFill>
-                      <a:srgbClr val="F8F9FA"/>
-                    </a:solidFill>
-                  </a:tcPr>
-                </a:tc>
-                <a:tc>
-                  <a:txBody>
-                    <a:bodyPr/>
-                    <a:lstStyle/>
-                    <a:p>
-                      <a:pPr>
-                        <a:defRPr sz="1000">
-                          <a:solidFill>
-                            <a:srgbClr val="1E2923"/>
-                          </a:solidFill>
-                          <a:latin typeface="Arial"/>
-                        </a:defRPr>
-                      </a:pPr>
-                      <a:r>
-                        <a:t>Student Presenters &amp; Reactor Panel</a:t>
+                        <a:t>Event Chairperson</a:t>
                       </a:r>
                     </a:p>
                   </a:txBody>
@@ -16004,14 +16050,14 @@
                   </a:tcPr>
                 </a:tc>
               </a:tr>
-              <a:tr h="786384">
+              <a:tr h="685800">
                 <a:tc>
                   <a:txBody>
                     <a:bodyPr/>
                     <a:lstStyle/>
                     <a:p>
                       <a:pPr>
-                        <a:defRPr sz="1000" b="1">
+                        <a:defRPr sz="950" b="1">
                           <a:solidFill>
                             <a:srgbClr val="1B4332"/>
                           </a:solidFill>
@@ -16019,7 +16065,7 @@
                         </a:defRPr>
                       </a:pPr>
                       <a:r>
-                        <a:t>02:30 PM – 03:15 PM</a:t>
+                        <a:t>11:50 AM – 12:00 NN</a:t>
                       </a:r>
                     </a:p>
                   </a:txBody>
@@ -16035,7 +16081,7 @@
                     <a:lstStyle/>
                     <a:p>
                       <a:pPr>
-                        <a:defRPr sz="1000" b="1">
+                        <a:defRPr sz="950">
                           <a:solidFill>
                             <a:srgbClr val="1E2923"/>
                           </a:solidFill>
@@ -16043,7 +16089,12 @@
                         </a:defRPr>
                       </a:pPr>
                       <a:r>
-                        <a:t>Awarding of Best Paper &amp; Certificates</a:t>
+                        <a:t>Closing Remarks &amp; Official Group Photo</a:t>
+                      </a:r>
+                    </a:p>
+                    <a:p>
+                      <a:r>
+                        <a:t>Formal adjournment of PECS 2026 followed by stage photo.</a:t>
                       </a:r>
                     </a:p>
                   </a:txBody>
@@ -16059,7 +16110,7 @@
                     <a:lstStyle/>
                     <a:p>
                       <a:pPr>
-                        <a:defRPr sz="1000">
+                        <a:defRPr sz="950">
                           <a:solidFill>
                             <a:srgbClr val="1E2923"/>
                           </a:solidFill>
@@ -16067,31 +16118,7 @@
                         </a:defRPr>
                       </a:pPr>
                       <a:r>
-                        <a:t>Conferment of Plaque of Appreciation to speakers and Best Student Research Presentation.</a:t>
-                      </a:r>
-                    </a:p>
-                  </a:txBody>
-                  <a:tcPr>
-                    <a:solidFill>
-                      <a:srgbClr val="FFFFFF"/>
-                    </a:solidFill>
-                  </a:tcPr>
-                </a:tc>
-                <a:tc>
-                  <a:txBody>
-                    <a:bodyPr/>
-                    <a:lstStyle/>
-                    <a:p>
-                      <a:pPr>
-                        <a:defRPr sz="1000">
-                          <a:solidFill>
-                            <a:srgbClr val="1E2923"/>
-                          </a:solidFill>
-                          <a:latin typeface="Arial"/>
-                        </a:defRPr>
-                      </a:pPr>
-                      <a:r>
-                        <a:t>Conference Director &amp; CHTM Dean</a:t>
+                        <a:t>Organizers &amp; Attendees</a:t>
                       </a:r>
                     </a:p>
                   </a:txBody>
@@ -16102,104 +16129,6 @@
                   </a:tcPr>
                 </a:tc>
               </a:tr>
-              <a:tr h="786384">
-                <a:tc>
-                  <a:txBody>
-                    <a:bodyPr/>
-                    <a:lstStyle/>
-                    <a:p>
-                      <a:pPr>
-                        <a:defRPr sz="1000" b="1">
-                          <a:solidFill>
-                            <a:srgbClr val="1B4332"/>
-                          </a:solidFill>
-                          <a:latin typeface="Arial"/>
-                        </a:defRPr>
-                      </a:pPr>
-                      <a:r>
-                        <a:t>03:15 PM – 03:30 PM</a:t>
-                      </a:r>
-                    </a:p>
-                  </a:txBody>
-                  <a:tcPr>
-                    <a:solidFill>
-                      <a:srgbClr val="F8F9FA"/>
-                    </a:solidFill>
-                  </a:tcPr>
-                </a:tc>
-                <a:tc>
-                  <a:txBody>
-                    <a:bodyPr/>
-                    <a:lstStyle/>
-                    <a:p>
-                      <a:pPr>
-                        <a:defRPr sz="1000" b="1">
-                          <a:solidFill>
-                            <a:srgbClr val="1E2923"/>
-                          </a:solidFill>
-                          <a:latin typeface="Arial"/>
-                        </a:defRPr>
-                      </a:pPr>
-                      <a:r>
-                        <a:t>Closing Remarks &amp; Photo Session</a:t>
-                      </a:r>
-                    </a:p>
-                  </a:txBody>
-                  <a:tcPr>
-                    <a:solidFill>
-                      <a:srgbClr val="F8F9FA"/>
-                    </a:solidFill>
-                  </a:tcPr>
-                </a:tc>
-                <a:tc>
-                  <a:txBody>
-                    <a:bodyPr/>
-                    <a:lstStyle/>
-                    <a:p>
-                      <a:pPr>
-                        <a:defRPr sz="1000">
-                          <a:solidFill>
-                            <a:srgbClr val="1E2923"/>
-                          </a:solidFill>
-                          <a:latin typeface="Arial"/>
-                        </a:defRPr>
-                      </a:pPr>
-                      <a:r>
-                        <a:t>Formal adjournment of PECS 2026 Conference followed by group photo on the main stage.</a:t>
-                      </a:r>
-                    </a:p>
-                  </a:txBody>
-                  <a:tcPr>
-                    <a:solidFill>
-                      <a:srgbClr val="F8F9FA"/>
-                    </a:solidFill>
-                  </a:tcPr>
-                </a:tc>
-                <a:tc>
-                  <a:txBody>
-                    <a:bodyPr/>
-                    <a:lstStyle/>
-                    <a:p>
-                      <a:pPr>
-                        <a:defRPr sz="1000">
-                          <a:solidFill>
-                            <a:srgbClr val="1E2923"/>
-                          </a:solidFill>
-                          <a:latin typeface="Arial"/>
-                        </a:defRPr>
-                      </a:pPr>
-                      <a:r>
-                        <a:t>Conference Director</a:t>
-                      </a:r>
-                    </a:p>
-                  </a:txBody>
-                  <a:tcPr>
-                    <a:solidFill>
-                      <a:srgbClr val="F8F9FA"/>
-                    </a:solidFill>
-                  </a:tcPr>
-                </a:tc>
-              </a:tr>
             </a:tbl>
           </a:graphicData>
         </a:graphic>
@@ -16212,8 +16141,8 @@
         </p:nvSpPr>
         <p:spPr>
           <a:xfrm>
-            <a:off x="731520" y="5486400"/>
-            <a:ext cx="10728655" cy="777240"/>
+            <a:off x="731520" y="5623560"/>
+            <a:ext cx="10728655" cy="685800"/>
           </a:xfrm>
           <a:prstGeom prst="roundRect">
             <a:avLst/>
@@ -16257,8 +16186,8 @@
         </p:nvSpPr>
         <p:spPr>
           <a:xfrm>
-            <a:off x="914400" y="5532120"/>
-            <a:ext cx="10332720" cy="685800"/>
+            <a:off x="914400" y="5650992"/>
+            <a:ext cx="10332720" cy="621792"/>
           </a:xfrm>
           <a:prstGeom prst="rect">
             <a:avLst/>
@@ -16272,7 +16201,7 @@
           <a:lstStyle/>
           <a:p>
             <a:pPr>
-              <a:defRPr b="1" sz="1100">
+              <a:defRPr b="1" sz="1050">
                 <a:solidFill>
                   <a:srgbClr val="1B4332"/>
                 </a:solidFill>
@@ -16285,7 +16214,7 @@
           </a:p>
           <a:p>
             <a:pPr>
-              <a:defRPr sz="1000">
+              <a:defRPr sz="950">
                 <a:solidFill>
                   <a:srgbClr val="1E2923"/>
                 </a:solidFill>
@@ -16293,7 +16222,7 @@
               </a:defRPr>
             </a:pPr>
             <a:r>
-              <a:t>Each student presenter is allocated 15 minutes presentation + 5 minutes reactor critique. Stage timer monitors will be visible to enforce punctual program execution.</a:t>
+              <a:t>Each keynote speaker has 40 minutes presentation + 25 minutes interactive Q&amp;A. Floor microphones and stage countdown monitors ensure strict adherence to the 12:00 NN adjournment.</a:t>
             </a:r>
           </a:p>
         </p:txBody>
@@ -16981,7 +16910,7 @@
                         </a:defRPr>
                       </a:pPr>
                       <a:r>
-                        <a:t>Plated lunch and AM/PM snacks for invited guest speakers and panel reactors.</a:t>
+                        <a:t>Plated lunch and AM snacks for invited guest speakers and panel moderators.</a:t>
                       </a:r>
                     </a:p>
                   </a:txBody>
@@ -17055,7 +16984,7 @@
                         </a:defRPr>
                       </a:pPr>
                       <a:r>
-                        <a:t>Complete budget covering all 500 delegates and 10 VIP speakers.</a:t>
+                        <a:t>Complete budget covering all 500 delegates and VIP speakers.</a:t>
                       </a:r>
                     </a:p>
                   </a:txBody>
@@ -17178,7 +17107,7 @@
               </a:defRPr>
             </a:pPr>
             <a:r>
-              <a:t>Cost per delegate: ~₱120 (Highly cost-efficient academic staging)</a:t>
+              <a:t>Cost per delegate: ~₱120 (Cost-efficient academic staging)</a:t>
             </a:r>
           </a:p>
         </p:txBody>

</xml_diff>